<commit_message>
Adding filter stages in DOCs
</commit_message>
<xml_diff>
--- a/docs/source/hardware/adapter_cards/analog/uz_a_max11331/rj45_pinoutMAX11.pptx
+++ b/docs/source/hardware/adapter_cards/analog/uz_a_max11331/rj45_pinoutMAX11.pptx
@@ -8,6 +8,8 @@
     <p:sldId id="256" r:id="rId2"/>
     <p:sldId id="257" r:id="rId3"/>
     <p:sldId id="258" r:id="rId4"/>
+    <p:sldId id="259" r:id="rId5"/>
+    <p:sldId id="260" r:id="rId6"/>
   </p:sldIdLst>
   <p:sldSz cx="12192000" cy="6858000"/>
   <p:notesSz cx="6858000" cy="9144000"/>
@@ -1330,7 +1332,7 @@
           <a:p>
             <a:fld id="{F2B86341-4ACE-4CB8-8AB9-F01BA3CD47E8}" type="datetimeFigureOut">
               <a:rPr lang="de-DE" smtClean="0"/>
-              <a:t>01.01.2025</a:t>
+              <a:t>12.01.2025</a:t>
             </a:fld>
             <a:endParaRPr lang="de-DE"/>
           </a:p>
@@ -1498,7 +1500,7 @@
           <a:p>
             <a:fld id="{F2B86341-4ACE-4CB8-8AB9-F01BA3CD47E8}" type="datetimeFigureOut">
               <a:rPr lang="de-DE" smtClean="0"/>
-              <a:t>01.01.2025</a:t>
+              <a:t>12.01.2025</a:t>
             </a:fld>
             <a:endParaRPr lang="de-DE"/>
           </a:p>
@@ -1676,7 +1678,7 @@
           <a:p>
             <a:fld id="{F2B86341-4ACE-4CB8-8AB9-F01BA3CD47E8}" type="datetimeFigureOut">
               <a:rPr lang="de-DE" smtClean="0"/>
-              <a:t>01.01.2025</a:t>
+              <a:t>12.01.2025</a:t>
             </a:fld>
             <a:endParaRPr lang="de-DE"/>
           </a:p>
@@ -1844,7 +1846,7 @@
           <a:p>
             <a:fld id="{F2B86341-4ACE-4CB8-8AB9-F01BA3CD47E8}" type="datetimeFigureOut">
               <a:rPr lang="de-DE" smtClean="0"/>
-              <a:t>01.01.2025</a:t>
+              <a:t>12.01.2025</a:t>
             </a:fld>
             <a:endParaRPr lang="de-DE"/>
           </a:p>
@@ -2089,7 +2091,7 @@
           <a:p>
             <a:fld id="{F2B86341-4ACE-4CB8-8AB9-F01BA3CD47E8}" type="datetimeFigureOut">
               <a:rPr lang="de-DE" smtClean="0"/>
-              <a:t>01.01.2025</a:t>
+              <a:t>12.01.2025</a:t>
             </a:fld>
             <a:endParaRPr lang="de-DE"/>
           </a:p>
@@ -2318,7 +2320,7 @@
           <a:p>
             <a:fld id="{F2B86341-4ACE-4CB8-8AB9-F01BA3CD47E8}" type="datetimeFigureOut">
               <a:rPr lang="de-DE" smtClean="0"/>
-              <a:t>01.01.2025</a:t>
+              <a:t>12.01.2025</a:t>
             </a:fld>
             <a:endParaRPr lang="de-DE"/>
           </a:p>
@@ -2682,7 +2684,7 @@
           <a:p>
             <a:fld id="{F2B86341-4ACE-4CB8-8AB9-F01BA3CD47E8}" type="datetimeFigureOut">
               <a:rPr lang="de-DE" smtClean="0"/>
-              <a:t>01.01.2025</a:t>
+              <a:t>12.01.2025</a:t>
             </a:fld>
             <a:endParaRPr lang="de-DE"/>
           </a:p>
@@ -2799,7 +2801,7 @@
           <a:p>
             <a:fld id="{F2B86341-4ACE-4CB8-8AB9-F01BA3CD47E8}" type="datetimeFigureOut">
               <a:rPr lang="de-DE" smtClean="0"/>
-              <a:t>01.01.2025</a:t>
+              <a:t>12.01.2025</a:t>
             </a:fld>
             <a:endParaRPr lang="de-DE"/>
           </a:p>
@@ -2894,7 +2896,7 @@
           <a:p>
             <a:fld id="{F2B86341-4ACE-4CB8-8AB9-F01BA3CD47E8}" type="datetimeFigureOut">
               <a:rPr lang="de-DE" smtClean="0"/>
-              <a:t>01.01.2025</a:t>
+              <a:t>12.01.2025</a:t>
             </a:fld>
             <a:endParaRPr lang="de-DE"/>
           </a:p>
@@ -3169,7 +3171,7 @@
           <a:p>
             <a:fld id="{F2B86341-4ACE-4CB8-8AB9-F01BA3CD47E8}" type="datetimeFigureOut">
               <a:rPr lang="de-DE" smtClean="0"/>
-              <a:t>01.01.2025</a:t>
+              <a:t>12.01.2025</a:t>
             </a:fld>
             <a:endParaRPr lang="de-DE"/>
           </a:p>
@@ -3421,7 +3423,7 @@
           <a:p>
             <a:fld id="{F2B86341-4ACE-4CB8-8AB9-F01BA3CD47E8}" type="datetimeFigureOut">
               <a:rPr lang="de-DE" smtClean="0"/>
-              <a:t>01.01.2025</a:t>
+              <a:t>12.01.2025</a:t>
             </a:fld>
             <a:endParaRPr lang="de-DE"/>
           </a:p>
@@ -3632,7 +3634,7 @@
           <a:p>
             <a:fld id="{F2B86341-4ACE-4CB8-8AB9-F01BA3CD47E8}" type="datetimeFigureOut">
               <a:rPr lang="de-DE" smtClean="0"/>
-              <a:t>01.01.2025</a:t>
+              <a:t>12.01.2025</a:t>
             </a:fld>
             <a:endParaRPr lang="de-DE"/>
           </a:p>
@@ -4916,6 +4918,560 @@
 </p:sld>
 </file>
 
+<file path=ppt/slides/slide4.xml><?xml version="1.0" encoding="utf-8"?>
+<p:sld xmlns:a="http://schemas.openxmlformats.org/drawingml/2006/main" xmlns:r="http://schemas.openxmlformats.org/officeDocument/2006/relationships" xmlns:p="http://schemas.openxmlformats.org/presentationml/2006/main">
+  <p:cSld>
+    <p:spTree>
+      <p:nvGrpSpPr>
+        <p:cNvPr id="1" name=""/>
+        <p:cNvGrpSpPr/>
+        <p:nvPr/>
+      </p:nvGrpSpPr>
+      <p:grpSpPr>
+        <a:xfrm>
+          <a:off x="0" y="0"/>
+          <a:ext cx="0" cy="0"/>
+          <a:chOff x="0" y="0"/>
+          <a:chExt cx="0" cy="0"/>
+        </a:xfrm>
+      </p:grpSpPr>
+      <p:pic>
+        <p:nvPicPr>
+          <p:cNvPr id="4" name="Grafik 3">
+            <a:extLst>
+              <a:ext uri="{FF2B5EF4-FFF2-40B4-BE49-F238E27FC236}">
+                <a16:creationId xmlns:a16="http://schemas.microsoft.com/office/drawing/2014/main" id="{E0F93DCD-6810-4217-8F4F-6CAA2650001F}"/>
+              </a:ext>
+            </a:extLst>
+          </p:cNvPr>
+          <p:cNvPicPr>
+            <a:picLocks noChangeAspect="1"/>
+          </p:cNvPicPr>
+          <p:nvPr/>
+        </p:nvPicPr>
+        <p:blipFill>
+          <a:blip r:embed="rId2">
+            <a:extLst>
+              <a:ext uri="{BEBA8EAE-BF5A-486C-A8C5-ECC9F3942E4B}">
+                <a14:imgProps xmlns:a14="http://schemas.microsoft.com/office/drawing/2010/main">
+                  <a14:imgLayer r:embed="rId3">
+                    <a14:imgEffect>
+                      <a14:backgroundRemoval t="2034" b="97613" l="1195" r="98749">
+                        <a14:foregroundMark x1="17861" y1="5924" x2="29124" y2="5747"/>
+                        <a14:foregroundMark x1="29124" y1="5747" x2="61263" y2="9019"/>
+                        <a14:foregroundMark x1="61263" y1="9019" x2="72924" y2="7869"/>
+                        <a14:foregroundMark x1="72924" y1="7869" x2="84300" y2="8488"/>
+                        <a14:foregroundMark x1="84300" y1="8488" x2="88965" y2="7073"/>
+                        <a14:foregroundMark x1="88965" y1="7073" x2="91695" y2="17507"/>
+                        <a14:foregroundMark x1="91695" y1="17507" x2="95051" y2="88859"/>
+                        <a14:foregroundMark x1="95051" y1="88859" x2="91411" y2="93811"/>
+                        <a14:foregroundMark x1="91411" y1="93811" x2="87201" y2="92219"/>
+                        <a14:foregroundMark x1="95506" y1="43148" x2="93060" y2="60831"/>
+                        <a14:foregroundMark x1="93060" y1="60831" x2="90614" y2="67197"/>
+                        <a14:foregroundMark x1="90614" y1="67197" x2="90273" y2="67374"/>
+                        <a14:foregroundMark x1="96871" y1="9019" x2="98180" y2="16622"/>
+                        <a14:foregroundMark x1="98180" y1="16622" x2="95734" y2="78957"/>
+                        <a14:foregroundMark x1="95734" y1="78957" x2="98066" y2="88417"/>
+                        <a14:foregroundMark x1="96246" y1="91512" x2="92036" y2="95137"/>
+                        <a14:foregroundMark x1="92036" y1="95137" x2="13424" y2="92750"/>
+                        <a14:foregroundMark x1="13424" y1="92750" x2="13879" y2="66048"/>
+                        <a14:foregroundMark x1="13879" y1="66048" x2="10637" y2="60654"/>
+                        <a14:foregroundMark x1="10637" y1="60654" x2="6428" y2="64456"/>
+                        <a14:foregroundMark x1="6428" y1="64456" x2="3527" y2="58798"/>
+                        <a14:foregroundMark x1="3527" y1="58798" x2="5859" y2="52785"/>
+                        <a14:foregroundMark x1="5859" y1="52785" x2="5518" y2="45889"/>
+                        <a14:foregroundMark x1="5518" y1="45889" x2="2218" y2="39788"/>
+                        <a14:foregroundMark x1="2218" y1="39788" x2="5404" y2="33245"/>
+                        <a14:foregroundMark x1="5404" y1="33245" x2="10580" y2="31830"/>
+                        <a14:foregroundMark x1="10580" y1="31830" x2="11263" y2="32803"/>
+                        <a14:foregroundMark x1="2844" y1="32449" x2="2787" y2="47657"/>
+                        <a14:foregroundMark x1="2787" y1="47657" x2="2730" y2="47745"/>
+                        <a14:foregroundMark x1="1251" y1="52166" x2="1934" y2="65075"/>
+                        <a14:foregroundMark x1="1365" y1="65429" x2="2389" y2="65429"/>
+                        <a14:foregroundMark x1="5802" y1="69319" x2="5973" y2="69938"/>
+                        <a14:foregroundMark x1="9215" y1="29001" x2="7679" y2="29797"/>
+                        <a14:foregroundMark x1="5745" y1="27321" x2="6257" y2="28382"/>
+                        <a14:foregroundMark x1="2503" y1="31742" x2="1365" y2="31742"/>
+                        <a14:foregroundMark x1="12628" y1="6366" x2="14334" y2="15827"/>
+                        <a14:foregroundMark x1="14334" y1="15827" x2="16724" y2="17772"/>
+                        <a14:foregroundMark x1="92662" y1="2387" x2="85210" y2="2387"/>
+                        <a14:foregroundMark x1="10182" y1="95668" x2="10353" y2="95844"/>
+                        <a14:foregroundMark x1="8817" y1="97613" x2="9386" y2="97259"/>
+                        <a14:foregroundMark x1="10068" y1="93634" x2="10182" y2="94430"/>
+                        <a14:foregroundMark x1="97042" y1="2210" x2="97156" y2="4951"/>
+                        <a14:foregroundMark x1="98407" y1="61804" x2="98749" y2="63926"/>
+                        <a14:foregroundMark x1="98521" y1="58267" x2="98692" y2="59328"/>
+                        <a14:foregroundMark x1="98464" y1="56676" x2="98578" y2="58355"/>
+                        <a14:foregroundMark x1="98578" y1="4244" x2="98123" y2="4421"/>
+                        <a14:foregroundMark x1="98578" y1="93103" x2="98237" y2="92661"/>
+                        <a14:foregroundMark x1="2446" y1="51636" x2="2446" y2="51636"/>
+                        <a14:backgroundMark x1="3413" y1="50398" x2="2332" y2="50221"/>
+                        <a14:backgroundMark x1="14562" y1="707" x2="16382" y2="707"/>
+                        <a14:backgroundMark x1="90330" y1="354" x2="91638" y2="0"/>
+                        <a14:backgroundMark x1="98237" y1="1149" x2="98692" y2="1680"/>
+                        <a14:backgroundMark x1="99204" y1="6808" x2="99602" y2="8753"/>
+                        <a14:backgroundMark x1="99659" y1="11141" x2="99659" y2="14766"/>
+                        <a14:backgroundMark x1="99659" y1="33775" x2="98757" y2="56628"/>
+                        <a14:backgroundMark x1="98890" y1="63872" x2="99033" y2="64368"/>
+                        <a14:backgroundMark x1="99374" y1="91070" x2="99602" y2="88594"/>
+                        <a14:backgroundMark x1="99488" y1="80637" x2="99374" y2="79045"/>
+                        <a14:backgroundMark x1="99488" y1="72679" x2="99204" y2="69850"/>
+                        <a14:backgroundMark x1="99317" y1="64810" x2="99374" y2="62865"/>
+                        <a14:backgroundMark x1="99317" y1="59328" x2="99716" y2="61096"/>
+                        <a14:backgroundMark x1="97668" y1="6278" x2="97895" y2="6366"/>
+                        <a14:backgroundMark x1="96985" y1="2387" x2="96928" y2="1945"/>
+                        <a14:backgroundMark x1="97099" y1="2034" x2="97099" y2="2387"/>
+                        <a14:backgroundMark x1="97554" y1="90981" x2="97782" y2="90893"/>
+                      </a14:backgroundRemoval>
+                    </a14:imgEffect>
+                  </a14:imgLayer>
+                </a14:imgProps>
+              </a:ext>
+            </a:extLst>
+          </a:blip>
+          <a:stretch>
+            <a:fillRect/>
+          </a:stretch>
+        </p:blipFill>
+        <p:spPr>
+          <a:xfrm>
+            <a:off x="766042" y="0"/>
+            <a:ext cx="10659915" cy="6858000"/>
+          </a:xfrm>
+          <a:prstGeom prst="rect">
+            <a:avLst/>
+          </a:prstGeom>
+        </p:spPr>
+      </p:pic>
+    </p:spTree>
+    <p:extLst>
+      <p:ext uri="{BB962C8B-B14F-4D97-AF65-F5344CB8AC3E}">
+        <p14:creationId xmlns:p14="http://schemas.microsoft.com/office/powerpoint/2010/main" val="3496670025"/>
+      </p:ext>
+    </p:extLst>
+  </p:cSld>
+  <p:clrMapOvr>
+    <a:masterClrMapping/>
+  </p:clrMapOvr>
+</p:sld>
+</file>
+
+<file path=ppt/slides/slide5.xml><?xml version="1.0" encoding="utf-8"?>
+<p:sld xmlns:a="http://schemas.openxmlformats.org/drawingml/2006/main" xmlns:r="http://schemas.openxmlformats.org/officeDocument/2006/relationships" xmlns:p="http://schemas.openxmlformats.org/presentationml/2006/main">
+  <p:cSld>
+    <p:spTree>
+      <p:nvGrpSpPr>
+        <p:cNvPr id="1" name=""/>
+        <p:cNvGrpSpPr/>
+        <p:nvPr/>
+      </p:nvGrpSpPr>
+      <p:grpSpPr>
+        <a:xfrm>
+          <a:off x="0" y="0"/>
+          <a:ext cx="0" cy="0"/>
+          <a:chOff x="0" y="0"/>
+          <a:chExt cx="0" cy="0"/>
+        </a:xfrm>
+      </p:grpSpPr>
+      <p:pic>
+        <p:nvPicPr>
+          <p:cNvPr id="5" name="Grafik 4">
+            <a:extLst>
+              <a:ext uri="{FF2B5EF4-FFF2-40B4-BE49-F238E27FC236}">
+                <a16:creationId xmlns:a16="http://schemas.microsoft.com/office/drawing/2014/main" id="{76BCA102-2B3D-47A3-9F78-2F93ACC35EAE}"/>
+              </a:ext>
+            </a:extLst>
+          </p:cNvPr>
+          <p:cNvPicPr>
+            <a:picLocks noChangeAspect="1"/>
+          </p:cNvPicPr>
+          <p:nvPr/>
+        </p:nvPicPr>
+        <p:blipFill>
+          <a:blip r:embed="rId2" cstate="print">
+            <a:extLst>
+              <a:ext uri="{28A0092B-C50C-407E-A947-70E740481C1C}">
+                <a14:useLocalDpi xmlns:a14="http://schemas.microsoft.com/office/drawing/2010/main" val="0"/>
+              </a:ext>
+            </a:extLst>
+          </a:blip>
+          <a:stretch>
+            <a:fillRect/>
+          </a:stretch>
+        </p:blipFill>
+        <p:spPr>
+          <a:xfrm>
+            <a:off x="4251956" y="2250945"/>
+            <a:ext cx="3688088" cy="2356109"/>
+          </a:xfrm>
+          <a:prstGeom prst="rect">
+            <a:avLst/>
+          </a:prstGeom>
+        </p:spPr>
+      </p:pic>
+      <p:sp>
+        <p:nvSpPr>
+          <p:cNvPr id="6" name="Rechteck 5">
+            <a:extLst>
+              <a:ext uri="{FF2B5EF4-FFF2-40B4-BE49-F238E27FC236}">
+                <a16:creationId xmlns:a16="http://schemas.microsoft.com/office/drawing/2014/main" id="{82979712-7904-4F03-97E3-B30DFE3FAC12}"/>
+              </a:ext>
+            </a:extLst>
+          </p:cNvPr>
+          <p:cNvSpPr/>
+          <p:nvPr/>
+        </p:nvSpPr>
+        <p:spPr>
+          <a:xfrm>
+            <a:off x="4256718" y="3138488"/>
+            <a:ext cx="350043" cy="1304925"/>
+          </a:xfrm>
+          <a:prstGeom prst="rect">
+            <a:avLst/>
+          </a:prstGeom>
+          <a:solidFill>
+            <a:schemeClr val="bg1"/>
+          </a:solidFill>
+          <a:ln>
+            <a:solidFill>
+              <a:schemeClr val="bg1"/>
+            </a:solidFill>
+          </a:ln>
+        </p:spPr>
+        <p:style>
+          <a:lnRef idx="2">
+            <a:schemeClr val="accent1">
+              <a:shade val="50000"/>
+            </a:schemeClr>
+          </a:lnRef>
+          <a:fillRef idx="1">
+            <a:schemeClr val="accent1"/>
+          </a:fillRef>
+          <a:effectRef idx="0">
+            <a:schemeClr val="accent1"/>
+          </a:effectRef>
+          <a:fontRef idx="minor">
+            <a:schemeClr val="lt1"/>
+          </a:fontRef>
+        </p:style>
+        <p:txBody>
+          <a:bodyPr rtlCol="0" anchor="ctr"/>
+          <a:lstStyle/>
+          <a:p>
+            <a:pPr algn="ctr"/>
+            <a:endParaRPr lang="de-DE"/>
+          </a:p>
+        </p:txBody>
+      </p:sp>
+      <p:sp>
+        <p:nvSpPr>
+          <p:cNvPr id="7" name="Rechteck 6">
+            <a:extLst>
+              <a:ext uri="{FF2B5EF4-FFF2-40B4-BE49-F238E27FC236}">
+                <a16:creationId xmlns:a16="http://schemas.microsoft.com/office/drawing/2014/main" id="{4A9CA0B1-0701-40E9-904C-225682603770}"/>
+              </a:ext>
+            </a:extLst>
+          </p:cNvPr>
+          <p:cNvSpPr/>
+          <p:nvPr/>
+        </p:nvSpPr>
+        <p:spPr>
+          <a:xfrm>
+            <a:off x="5992650" y="4133850"/>
+            <a:ext cx="1777369" cy="152400"/>
+          </a:xfrm>
+          <a:prstGeom prst="rect">
+            <a:avLst/>
+          </a:prstGeom>
+          <a:solidFill>
+            <a:schemeClr val="bg1"/>
+          </a:solidFill>
+          <a:ln>
+            <a:solidFill>
+              <a:schemeClr val="bg1"/>
+            </a:solidFill>
+          </a:ln>
+        </p:spPr>
+        <p:style>
+          <a:lnRef idx="2">
+            <a:schemeClr val="accent1">
+              <a:shade val="50000"/>
+            </a:schemeClr>
+          </a:lnRef>
+          <a:fillRef idx="1">
+            <a:schemeClr val="accent1"/>
+          </a:fillRef>
+          <a:effectRef idx="0">
+            <a:schemeClr val="accent1"/>
+          </a:effectRef>
+          <a:fontRef idx="minor">
+            <a:schemeClr val="lt1"/>
+          </a:fontRef>
+        </p:style>
+        <p:txBody>
+          <a:bodyPr rtlCol="0" anchor="ctr"/>
+          <a:lstStyle/>
+          <a:p>
+            <a:pPr algn="ctr"/>
+            <a:endParaRPr lang="de-DE"/>
+          </a:p>
+        </p:txBody>
+      </p:sp>
+      <p:sp>
+        <p:nvSpPr>
+          <p:cNvPr id="8" name="Rechteck 7">
+            <a:extLst>
+              <a:ext uri="{FF2B5EF4-FFF2-40B4-BE49-F238E27FC236}">
+                <a16:creationId xmlns:a16="http://schemas.microsoft.com/office/drawing/2014/main" id="{02C25B53-9088-4B0E-B6E2-0A3F9325E4F6}"/>
+              </a:ext>
+            </a:extLst>
+          </p:cNvPr>
+          <p:cNvSpPr/>
+          <p:nvPr/>
+        </p:nvSpPr>
+        <p:spPr>
+          <a:xfrm>
+            <a:off x="4621051" y="4143374"/>
+            <a:ext cx="941549" cy="152400"/>
+          </a:xfrm>
+          <a:prstGeom prst="rect">
+            <a:avLst/>
+          </a:prstGeom>
+          <a:solidFill>
+            <a:schemeClr val="bg1"/>
+          </a:solidFill>
+          <a:ln>
+            <a:solidFill>
+              <a:schemeClr val="bg1"/>
+            </a:solidFill>
+          </a:ln>
+        </p:spPr>
+        <p:style>
+          <a:lnRef idx="2">
+            <a:schemeClr val="accent1">
+              <a:shade val="50000"/>
+            </a:schemeClr>
+          </a:lnRef>
+          <a:fillRef idx="1">
+            <a:schemeClr val="accent1"/>
+          </a:fillRef>
+          <a:effectRef idx="0">
+            <a:schemeClr val="accent1"/>
+          </a:effectRef>
+          <a:fontRef idx="minor">
+            <a:schemeClr val="lt1"/>
+          </a:fontRef>
+        </p:style>
+        <p:txBody>
+          <a:bodyPr rtlCol="0" anchor="ctr"/>
+          <a:lstStyle/>
+          <a:p>
+            <a:pPr algn="ctr"/>
+            <a:endParaRPr lang="de-DE"/>
+          </a:p>
+        </p:txBody>
+      </p:sp>
+      <p:sp>
+        <p:nvSpPr>
+          <p:cNvPr id="9" name="Rechteck 8">
+            <a:extLst>
+              <a:ext uri="{FF2B5EF4-FFF2-40B4-BE49-F238E27FC236}">
+                <a16:creationId xmlns:a16="http://schemas.microsoft.com/office/drawing/2014/main" id="{7142EEC3-0AE7-4330-B609-35E75D874CBE}"/>
+              </a:ext>
+            </a:extLst>
+          </p:cNvPr>
+          <p:cNvSpPr/>
+          <p:nvPr/>
+        </p:nvSpPr>
+        <p:spPr>
+          <a:xfrm>
+            <a:off x="7542843" y="3290886"/>
+            <a:ext cx="350043" cy="1304925"/>
+          </a:xfrm>
+          <a:prstGeom prst="rect">
+            <a:avLst/>
+          </a:prstGeom>
+          <a:solidFill>
+            <a:schemeClr val="bg1"/>
+          </a:solidFill>
+          <a:ln>
+            <a:solidFill>
+              <a:schemeClr val="bg1"/>
+            </a:solidFill>
+          </a:ln>
+        </p:spPr>
+        <p:style>
+          <a:lnRef idx="2">
+            <a:schemeClr val="accent1">
+              <a:shade val="50000"/>
+            </a:schemeClr>
+          </a:lnRef>
+          <a:fillRef idx="1">
+            <a:schemeClr val="accent1"/>
+          </a:fillRef>
+          <a:effectRef idx="0">
+            <a:schemeClr val="accent1"/>
+          </a:effectRef>
+          <a:fontRef idx="minor">
+            <a:schemeClr val="lt1"/>
+          </a:fontRef>
+        </p:style>
+        <p:txBody>
+          <a:bodyPr rtlCol="0" anchor="ctr"/>
+          <a:lstStyle/>
+          <a:p>
+            <a:pPr algn="ctr"/>
+            <a:endParaRPr lang="de-DE"/>
+          </a:p>
+        </p:txBody>
+      </p:sp>
+      <p:sp>
+        <p:nvSpPr>
+          <p:cNvPr id="10" name="Rechteck 9">
+            <a:extLst>
+              <a:ext uri="{FF2B5EF4-FFF2-40B4-BE49-F238E27FC236}">
+                <a16:creationId xmlns:a16="http://schemas.microsoft.com/office/drawing/2014/main" id="{EA329897-955B-44BA-8848-8417BB33D478}"/>
+              </a:ext>
+            </a:extLst>
+          </p:cNvPr>
+          <p:cNvSpPr/>
+          <p:nvPr/>
+        </p:nvSpPr>
+        <p:spPr>
+          <a:xfrm>
+            <a:off x="5591177" y="4186237"/>
+            <a:ext cx="385760" cy="152400"/>
+          </a:xfrm>
+          <a:prstGeom prst="rect">
+            <a:avLst/>
+          </a:prstGeom>
+          <a:solidFill>
+            <a:schemeClr val="bg1"/>
+          </a:solidFill>
+          <a:ln>
+            <a:solidFill>
+              <a:schemeClr val="bg1"/>
+            </a:solidFill>
+          </a:ln>
+        </p:spPr>
+        <p:style>
+          <a:lnRef idx="2">
+            <a:schemeClr val="accent1">
+              <a:shade val="50000"/>
+            </a:schemeClr>
+          </a:lnRef>
+          <a:fillRef idx="1">
+            <a:schemeClr val="accent1"/>
+          </a:fillRef>
+          <a:effectRef idx="0">
+            <a:schemeClr val="accent1"/>
+          </a:effectRef>
+          <a:fontRef idx="minor">
+            <a:schemeClr val="lt1"/>
+          </a:fontRef>
+        </p:style>
+        <p:txBody>
+          <a:bodyPr rtlCol="0" anchor="ctr"/>
+          <a:lstStyle/>
+          <a:p>
+            <a:pPr algn="ctr"/>
+            <a:endParaRPr lang="de-DE"/>
+          </a:p>
+        </p:txBody>
+      </p:sp>
+      <p:sp>
+        <p:nvSpPr>
+          <p:cNvPr id="11" name="Textfeld 10">
+            <a:extLst>
+              <a:ext uri="{FF2B5EF4-FFF2-40B4-BE49-F238E27FC236}">
+                <a16:creationId xmlns:a16="http://schemas.microsoft.com/office/drawing/2014/main" id="{4956FF32-C3E6-402D-9A17-38757FF50982}"/>
+              </a:ext>
+            </a:extLst>
+          </p:cNvPr>
+          <p:cNvSpPr txBox="1"/>
+          <p:nvPr/>
+        </p:nvSpPr>
+        <p:spPr>
+          <a:xfrm>
+            <a:off x="4929188" y="3167389"/>
+            <a:ext cx="391454" cy="261610"/>
+          </a:xfrm>
+          <a:prstGeom prst="rect">
+            <a:avLst/>
+          </a:prstGeom>
+          <a:noFill/>
+        </p:spPr>
+        <p:txBody>
+          <a:bodyPr wrap="none" rtlCol="0">
+            <a:spAutoFit/>
+          </a:bodyPr>
+          <a:lstStyle/>
+          <a:p>
+            <a:r>
+              <a:rPr lang="de-DE" sz="1050" dirty="0"/>
+              <a:t>R</a:t>
+            </a:r>
+            <a:r>
+              <a:rPr lang="de-DE" sz="1050" baseline="-25000" dirty="0"/>
+              <a:t>pt1</a:t>
+            </a:r>
+          </a:p>
+        </p:txBody>
+      </p:sp>
+      <p:sp>
+        <p:nvSpPr>
+          <p:cNvPr id="12" name="Textfeld 11">
+            <a:extLst>
+              <a:ext uri="{FF2B5EF4-FFF2-40B4-BE49-F238E27FC236}">
+                <a16:creationId xmlns:a16="http://schemas.microsoft.com/office/drawing/2014/main" id="{0FD22AC0-5A59-4160-A2D6-845E066C6DCA}"/>
+              </a:ext>
+            </a:extLst>
+          </p:cNvPr>
+          <p:cNvSpPr txBox="1"/>
+          <p:nvPr/>
+        </p:nvSpPr>
+        <p:spPr>
+          <a:xfrm>
+            <a:off x="5056789" y="3578178"/>
+            <a:ext cx="391454" cy="253916"/>
+          </a:xfrm>
+          <a:prstGeom prst="rect">
+            <a:avLst/>
+          </a:prstGeom>
+          <a:solidFill>
+            <a:schemeClr val="bg1"/>
+          </a:solidFill>
+        </p:spPr>
+        <p:txBody>
+          <a:bodyPr wrap="square" rtlCol="0">
+            <a:spAutoFit/>
+          </a:bodyPr>
+          <a:lstStyle/>
+          <a:p>
+            <a:r>
+              <a:rPr lang="de-DE" sz="1050" dirty="0"/>
+              <a:t>C</a:t>
+            </a:r>
+            <a:r>
+              <a:rPr lang="de-DE" sz="1050" baseline="-25000" dirty="0"/>
+              <a:t>pt1</a:t>
+            </a:r>
+          </a:p>
+        </p:txBody>
+      </p:sp>
+    </p:spTree>
+    <p:extLst>
+      <p:ext uri="{BB962C8B-B14F-4D97-AF65-F5344CB8AC3E}">
+        <p14:creationId xmlns:p14="http://schemas.microsoft.com/office/powerpoint/2010/main" val="2279269972"/>
+      </p:ext>
+    </p:extLst>
+  </p:cSld>
+  <p:clrMapOvr>
+    <a:masterClrMapping/>
+  </p:clrMapOvr>
+</p:sld>
+</file>
+
 <file path=ppt/theme/theme1.xml><?xml version="1.0" encoding="utf-8"?>
 <a:theme xmlns:a="http://schemas.openxmlformats.org/drawingml/2006/main" name="Office">
   <a:themeElements>

</xml_diff>